<commit_message>
docs: align FSM diagrams with slides/report text and fix title slide layout
- Update FSM text on slides 14 and 16 to match updated Draw.io diagrams.
- Rename FSP references to FSM in report (Chapter 2) to fix missing figure errors.
- Adjust vertical spacing on the title slide to prevent header overlap and footer overflow.
</commit_message>
<xml_diff>
--- a/Presentation/EmbeddedC_backup.pptx
+++ b/Presentation/EmbeddedC_backup.pptx
@@ -235,7 +235,7 @@
           <a:p>
             <a:fld id="{56A7BB98-F82A-4C83-B55E-2344AB225101}" type="datetimeFigureOut">
               <a:rPr lang="vi-VN" smtClean="0"/>
-              <a:t>23/08/2026</a:t>
+              <a:t>27/08/2026</a:t>
             </a:fld>
             <a:endParaRPr lang="vi-VN"/>
           </a:p>
@@ -850,7 +850,7 @@
           <a:p>
             <a:fld id="{5BCAD085-E8A6-8845-BD4E-CB4CCA059FC4}" type="datetimeFigureOut">
               <a:rPr lang="en-US" smtClean="0"/>
-              <a:t>8/23/2026</a:t>
+              <a:t>8/27/2026</a:t>
             </a:fld>
             <a:endParaRPr lang="en-US"/>
           </a:p>
@@ -1018,7 +1018,7 @@
           <a:p>
             <a:fld id="{5BCAD085-E8A6-8845-BD4E-CB4CCA059FC4}" type="datetimeFigureOut">
               <a:rPr lang="en-US" smtClean="0"/>
-              <a:t>8/23/2026</a:t>
+              <a:t>8/27/2026</a:t>
             </a:fld>
             <a:endParaRPr lang="en-US"/>
           </a:p>
@@ -1196,7 +1196,7 @@
           <a:p>
             <a:fld id="{5BCAD085-E8A6-8845-BD4E-CB4CCA059FC4}" type="datetimeFigureOut">
               <a:rPr lang="en-US" smtClean="0"/>
-              <a:t>8/23/2026</a:t>
+              <a:t>8/27/2026</a:t>
             </a:fld>
             <a:endParaRPr lang="en-US"/>
           </a:p>
@@ -1460,7 +1460,7 @@
           <a:p>
             <a:fld id="{1D8BD707-D9CF-40AE-B4C6-C98DA3205C09}" type="datetimeFigureOut">
               <a:rPr lang="en-US"/>
-              <a:t>8/23/2026</a:t>
+              <a:t>8/27/2026</a:t>
             </a:fld>
             <a:endParaRPr lang="en-US"/>
           </a:p>
@@ -1652,7 +1652,7 @@
           <a:p>
             <a:fld id="{1D8BD707-D9CF-40AE-B4C6-C98DA3205C09}" type="datetimeFigureOut">
               <a:rPr lang="en-US"/>
-              <a:t>8/23/2026</a:t>
+              <a:t>8/27/2026</a:t>
             </a:fld>
             <a:endParaRPr lang="en-US"/>
           </a:p>
@@ -1876,7 +1876,7 @@
           <a:p>
             <a:fld id="{1D8BD707-D9CF-40AE-B4C6-C98DA3205C09}" type="datetimeFigureOut">
               <a:rPr lang="en-US"/>
-              <a:t>8/23/2026</a:t>
+              <a:t>8/27/2026</a:t>
             </a:fld>
             <a:endParaRPr lang="en-US"/>
           </a:p>
@@ -2064,7 +2064,7 @@
           <a:p>
             <a:fld id="{1D8BD707-D9CF-40AE-B4C6-C98DA3205C09}" type="datetimeFigureOut">
               <a:rPr lang="en-US"/>
-              <a:t>8/23/2026</a:t>
+              <a:t>8/27/2026</a:t>
             </a:fld>
             <a:endParaRPr lang="en-US"/>
           </a:p>
@@ -2188,7 +2188,7 @@
           <a:p>
             <a:fld id="{1D8BD707-D9CF-40AE-B4C6-C98DA3205C09}" type="datetimeFigureOut">
               <a:rPr lang="en-US"/>
-              <a:t>8/23/2026</a:t>
+              <a:t>8/27/2026</a:t>
             </a:fld>
             <a:endParaRPr lang="en-US"/>
           </a:p>
@@ -2346,7 +2346,7 @@
           <a:p>
             <a:fld id="{5BCAD085-E8A6-8845-BD4E-CB4CCA059FC4}" type="datetimeFigureOut">
               <a:rPr lang="en-US" smtClean="0"/>
-              <a:t>8/23/2026</a:t>
+              <a:t>8/27/2026</a:t>
             </a:fld>
             <a:endParaRPr lang="en-US"/>
           </a:p>
@@ -2591,7 +2591,7 @@
           <a:p>
             <a:fld id="{5BCAD085-E8A6-8845-BD4E-CB4CCA059FC4}" type="datetimeFigureOut">
               <a:rPr lang="en-US" smtClean="0"/>
-              <a:t>8/23/2026</a:t>
+              <a:t>8/27/2026</a:t>
             </a:fld>
             <a:endParaRPr lang="en-US"/>
           </a:p>
@@ -2876,7 +2876,7 @@
           <a:p>
             <a:fld id="{5BCAD085-E8A6-8845-BD4E-CB4CCA059FC4}" type="datetimeFigureOut">
               <a:rPr lang="en-US" smtClean="0"/>
-              <a:t>8/23/2026</a:t>
+              <a:t>8/27/2026</a:t>
             </a:fld>
             <a:endParaRPr lang="en-US"/>
           </a:p>
@@ -3295,7 +3295,7 @@
           <a:p>
             <a:fld id="{5BCAD085-E8A6-8845-BD4E-CB4CCA059FC4}" type="datetimeFigureOut">
               <a:rPr lang="en-US" smtClean="0"/>
-              <a:t>8/23/2026</a:t>
+              <a:t>8/27/2026</a:t>
             </a:fld>
             <a:endParaRPr lang="en-US"/>
           </a:p>
@@ -3412,7 +3412,7 @@
           <a:p>
             <a:fld id="{5BCAD085-E8A6-8845-BD4E-CB4CCA059FC4}" type="datetimeFigureOut">
               <a:rPr lang="en-US" smtClean="0"/>
-              <a:t>8/23/2026</a:t>
+              <a:t>8/27/2026</a:t>
             </a:fld>
             <a:endParaRPr lang="en-US"/>
           </a:p>
@@ -3507,7 +3507,7 @@
           <a:p>
             <a:fld id="{5BCAD085-E8A6-8845-BD4E-CB4CCA059FC4}" type="datetimeFigureOut">
               <a:rPr lang="en-US" smtClean="0"/>
-              <a:t>8/23/2026</a:t>
+              <a:t>8/27/2026</a:t>
             </a:fld>
             <a:endParaRPr lang="en-US"/>
           </a:p>
@@ -3782,7 +3782,7 @@
           <a:p>
             <a:fld id="{5BCAD085-E8A6-8845-BD4E-CB4CCA059FC4}" type="datetimeFigureOut">
               <a:rPr lang="en-US" smtClean="0"/>
-              <a:t>8/23/2026</a:t>
+              <a:t>8/27/2026</a:t>
             </a:fld>
             <a:endParaRPr lang="en-US"/>
           </a:p>
@@ -4034,7 +4034,7 @@
           <a:p>
             <a:fld id="{5BCAD085-E8A6-8845-BD4E-CB4CCA059FC4}" type="datetimeFigureOut">
               <a:rPr lang="en-US" smtClean="0"/>
-              <a:t>8/23/2026</a:t>
+              <a:t>8/27/2026</a:t>
             </a:fld>
             <a:endParaRPr lang="en-US"/>
           </a:p>
@@ -4245,7 +4245,7 @@
           <a:p>
             <a:fld id="{5BCAD085-E8A6-8845-BD4E-CB4CCA059FC4}" type="datetimeFigureOut">
               <a:rPr lang="en-US" smtClean="0"/>
-              <a:t>8/23/2026</a:t>
+              <a:t>8/27/2026</a:t>
             </a:fld>
             <a:endParaRPr lang="en-US"/>
           </a:p>
@@ -4804,7 +4804,7 @@
           <a:p>
             <a:fld id="{1D8BD707-D9CF-40AE-B4C6-C98DA3205C09}" type="datetimeFigureOut">
               <a:rPr lang="en-US"/>
-              <a:t>8/23/2026</a:t>
+              <a:t>8/27/2026</a:t>
             </a:fld>
             <a:endParaRPr lang="en-US"/>
           </a:p>
@@ -11423,7 +11423,7 @@
           <a:p>
             <a:pPr algn="ctr"/>
             <a:r>
-              <a:rPr sz="1400" b="1">
+              <a:rPr sz="1400" b="1" dirty="0">
                 <a:solidFill>
                   <a:srgbClr val="1F4E79"/>
                 </a:solidFill>
@@ -11514,7 +11514,7 @@
           <a:p>
             <a:pPr algn="ctr"/>
             <a:r>
-              <a:rPr sz="1400" b="1">
+              <a:rPr sz="1400" b="1" dirty="0">
                 <a:solidFill>
                   <a:srgbClr val="1F4E79"/>
                 </a:solidFill>
@@ -11605,7 +11605,7 @@
           <a:p>
             <a:pPr algn="ctr"/>
             <a:r>
-              <a:rPr sz="1400" b="1">
+              <a:rPr sz="1400" b="1" dirty="0">
                 <a:solidFill>
                   <a:srgbClr val="1F4E79"/>
                 </a:solidFill>

</xml_diff>